<commit_message>
enhace the propmt and extraction of the metadata
</commit_message>
<xml_diff>
--- a/templates/template.pptx
+++ b/templates/template.pptx
@@ -202,7 +202,7 @@
           </a:lstStyle>
           <a:p>
             <a:fld id="{79D35C7A-7DCE-4476-B289-266B67A374E6}" type="datetimeFigureOut">
-              <a:t>5/11/2026</a:t>
+              <a:t>5/12/2026</a:t>
             </a:fld>
             <a:endParaRPr lang="en-US"/>
           </a:p>
@@ -994,6 +994,13 @@
           </a:solidFill>
           <a:ln/>
         </p:spPr>
+        <p:txBody>
+          <a:bodyPr/>
+          <a:lstStyle/>
+          <a:p>
+            <a:endParaRPr lang="en-GB"/>
+          </a:p>
+        </p:txBody>
       </p:sp>
       <p:sp>
         <p:nvSpPr>
@@ -1088,6 +1095,13 @@
           </a:solidFill>
           <a:ln/>
         </p:spPr>
+        <p:txBody>
+          <a:bodyPr/>
+          <a:lstStyle/>
+          <a:p>
+            <a:endParaRPr lang="en-GB"/>
+          </a:p>
+        </p:txBody>
       </p:sp>
       <p:sp>
         <p:nvSpPr>
@@ -1097,7 +1111,7 @@
         </p:nvSpPr>
         <p:spPr>
           <a:xfrm>
-            <a:off x="754380" y="1920240"/>
+            <a:off x="822960" y="2571750"/>
             <a:ext cx="7132320" cy="1463040"/>
           </a:xfrm>
           <a:prstGeom prst="rect">
@@ -1116,16 +1130,30 @@
               </a:lnSpc>
             </a:pPr>
             <a:r>
-              <a:rPr lang="en-US" sz="1600">
+              <a:rPr lang="en-US" sz="1600" dirty="0">
                 <a:solidFill>
                   <a:srgbClr val="E8E8E8"/>
                 </a:solidFill>
                 <a:ea typeface="+mn-lt"/>
                 <a:cs typeface="+mn-lt"/>
               </a:rPr>
-              <a:t>{{summary}}</a:t>
+              <a:t>{{summary_</a:t>
             </a:r>
-            <a:endParaRPr lang="en-US"/>
+            <a:r>
+              <a:rPr lang="en-GB" dirty="0"/>
+              <a:t>paragraph</a:t>
+            </a:r>
+            <a:r>
+              <a:rPr lang="en-US" sz="1600" dirty="0">
+                <a:solidFill>
+                  <a:srgbClr val="E8E8E8"/>
+                </a:solidFill>
+                <a:ea typeface="+mn-lt"/>
+                <a:cs typeface="+mn-lt"/>
+              </a:rPr>
+              <a:t>}}</a:t>
+            </a:r>
+            <a:endParaRPr lang="en-US" dirty="0"/>
           </a:p>
         </p:txBody>
       </p:sp>
@@ -1183,6 +1211,13 @@
           </a:solidFill>
           <a:ln/>
         </p:spPr>
+        <p:txBody>
+          <a:bodyPr/>
+          <a:lstStyle/>
+          <a:p>
+            <a:endParaRPr lang="en-GB"/>
+          </a:p>
+        </p:txBody>
       </p:sp>
       <p:sp>
         <p:nvSpPr>
@@ -1300,6 +1335,13 @@
           </a:solidFill>
           <a:ln/>
         </p:spPr>
+        <p:txBody>
+          <a:bodyPr/>
+          <a:lstStyle/>
+          <a:p>
+            <a:endParaRPr lang="en-GB"/>
+          </a:p>
+        </p:txBody>
       </p:sp>
       <p:sp>
         <p:nvSpPr>

</xml_diff>